<commit_message>
Use-case slides: ASU brand colors (maroon header, gold accent, white bg)
</commit_message>
<xml_diff>
--- a/C3D-FBX-ASU-Presentation.pptx
+++ b/C3D-FBX-ASU-Presentation.pptx
@@ -8,8 +8,8 @@
     <p:sldId id="256" r:id="rId7"/>
     <p:sldId id="257" r:id="rId8"/>
     <p:sldId id="258" r:id="rId9"/>
-    <p:sldId id="268" r:id="rId19"/>
-    <p:sldId id="269" r:id="rId20"/>
+    <p:sldId id="270" r:id="rId18"/>
+    <p:sldId id="271" r:id="rId21"/>
     <p:sldId id="259" r:id="rId10"/>
     <p:sldId id="260" r:id="rId11"/>
     <p:sldId id="261" r:id="rId12"/>
@@ -6394,6 +6394,1304 @@
 </p:sld>
 </file>
 
+<file path=ppt/slides/slide14.xml><?xml version="1.0" encoding="utf-8"?>
+<p:sld xmlns:a="http://schemas.openxmlformats.org/drawingml/2006/main" xmlns:p="http://schemas.openxmlformats.org/presentationml/2006/main" xmlns:r="http://schemas.openxmlformats.org/officeDocument/2006/relationships">
+  <p:cSld>
+    <p:spTree>
+      <p:nvGrpSpPr>
+        <p:cNvPr id="1" name=""/>
+        <p:cNvGrpSpPr/>
+        <p:nvPr/>
+      </p:nvGrpSpPr>
+      <p:grpSpPr/>
+      <p:sp>
+        <p:nvSpPr>
+          <p:cNvPr id="2" name="Rectangle 1"/>
+          <p:cNvSpPr/>
+          <p:nvPr/>
+        </p:nvSpPr>
+        <p:spPr>
+          <a:xfrm>
+            <a:off x="0" y="0"/>
+            <a:ext cx="12188952" cy="6858000"/>
+          </a:xfrm>
+          <a:prstGeom prst="rect">
+            <a:avLst/>
+          </a:prstGeom>
+          <a:solidFill>
+            <a:srgbClr val="FFFFFF"/>
+          </a:solidFill>
+          <a:ln>
+            <a:noFill/>
+          </a:ln>
+        </p:spPr>
+        <p:style>
+          <a:lnRef idx="1">
+            <a:schemeClr val="accent1"/>
+          </a:lnRef>
+          <a:fillRef idx="3">
+            <a:schemeClr val="accent1"/>
+          </a:fillRef>
+          <a:effectRef idx="2">
+            <a:schemeClr val="accent1"/>
+          </a:effectRef>
+          <a:fontRef idx="minor">
+            <a:schemeClr val="lt1"/>
+          </a:fontRef>
+        </p:style>
+        <p:txBody>
+          <a:bodyPr rtlCol="0" anchor="ctr"/>
+          <a:lstStyle/>
+          <a:p>
+            <a:pPr algn="ctr"/>
+          </a:p>
+        </p:txBody>
+      </p:sp>
+      <p:sp>
+        <p:nvSpPr>
+          <p:cNvPr id="3" name="Rectangle 2"/>
+          <p:cNvSpPr/>
+          <p:nvPr/>
+        </p:nvSpPr>
+        <p:spPr>
+          <a:xfrm>
+            <a:off x="0" y="0"/>
+            <a:ext cx="12188952" cy="1005840"/>
+          </a:xfrm>
+          <a:prstGeom prst="rect">
+            <a:avLst/>
+          </a:prstGeom>
+          <a:solidFill>
+            <a:srgbClr val="8C1D40"/>
+          </a:solidFill>
+          <a:ln>
+            <a:noFill/>
+          </a:ln>
+        </p:spPr>
+        <p:style>
+          <a:lnRef idx="1">
+            <a:schemeClr val="accent1"/>
+          </a:lnRef>
+          <a:fillRef idx="3">
+            <a:schemeClr val="accent1"/>
+          </a:fillRef>
+          <a:effectRef idx="2">
+            <a:schemeClr val="accent1"/>
+          </a:effectRef>
+          <a:fontRef idx="minor">
+            <a:schemeClr val="lt1"/>
+          </a:fontRef>
+        </p:style>
+        <p:txBody>
+          <a:bodyPr rtlCol="0" anchor="ctr"/>
+          <a:lstStyle/>
+          <a:p>
+            <a:pPr algn="ctr"/>
+          </a:p>
+        </p:txBody>
+      </p:sp>
+      <p:sp>
+        <p:nvSpPr>
+          <p:cNvPr id="4" name="Rectangle 3"/>
+          <p:cNvSpPr/>
+          <p:nvPr/>
+        </p:nvSpPr>
+        <p:spPr>
+          <a:xfrm>
+            <a:off x="0" y="1005840"/>
+            <a:ext cx="12188952" cy="64008"/>
+          </a:xfrm>
+          <a:prstGeom prst="rect">
+            <a:avLst/>
+          </a:prstGeom>
+          <a:solidFill>
+            <a:srgbClr val="FFC627"/>
+          </a:solidFill>
+          <a:ln>
+            <a:noFill/>
+          </a:ln>
+        </p:spPr>
+        <p:style>
+          <a:lnRef idx="1">
+            <a:schemeClr val="accent1"/>
+          </a:lnRef>
+          <a:fillRef idx="3">
+            <a:schemeClr val="accent1"/>
+          </a:fillRef>
+          <a:effectRef idx="2">
+            <a:schemeClr val="accent1"/>
+          </a:effectRef>
+          <a:fontRef idx="minor">
+            <a:schemeClr val="lt1"/>
+          </a:fontRef>
+        </p:style>
+        <p:txBody>
+          <a:bodyPr rtlCol="0" anchor="ctr"/>
+          <a:lstStyle/>
+          <a:p>
+            <a:pPr algn="ctr"/>
+          </a:p>
+        </p:txBody>
+      </p:sp>
+      <p:sp>
+        <p:nvSpPr>
+          <p:cNvPr id="5" name="TextBox 4"/>
+          <p:cNvSpPr txBox="1"/>
+          <p:nvPr/>
+        </p:nvSpPr>
+        <p:spPr>
+          <a:xfrm>
+            <a:off x="457200" y="91440"/>
+            <a:ext cx="11274552" cy="502920"/>
+          </a:xfrm>
+          <a:prstGeom prst="rect">
+            <a:avLst/>
+          </a:prstGeom>
+          <a:noFill/>
+        </p:spPr>
+        <p:txBody>
+          <a:bodyPr wrap="none">
+            <a:spAutoFit/>
+          </a:bodyPr>
+          <a:lstStyle/>
+          <a:p>
+            <a:r>
+              <a:rPr sz="3000" b="1">
+                <a:solidFill>
+                  <a:srgbClr val="FFFFFF"/>
+                </a:solidFill>
+              </a:rPr>
+              <a:t>USE CASE: PHYSICAL THERAPY</a:t>
+            </a:r>
+          </a:p>
+        </p:txBody>
+      </p:sp>
+      <p:sp>
+        <p:nvSpPr>
+          <p:cNvPr id="6" name="TextBox 5"/>
+          <p:cNvSpPr txBox="1"/>
+          <p:nvPr/>
+        </p:nvSpPr>
+        <p:spPr>
+          <a:xfrm>
+            <a:off x="457200" y="594360"/>
+            <a:ext cx="11274552" cy="320040"/>
+          </a:xfrm>
+          <a:prstGeom prst="rect">
+            <a:avLst/>
+          </a:prstGeom>
+          <a:noFill/>
+        </p:spPr>
+        <p:txBody>
+          <a:bodyPr wrap="none">
+            <a:spAutoFit/>
+          </a:bodyPr>
+          <a:lstStyle/>
+          <a:p>
+            <a:r>
+              <a:rPr sz="1400" b="0">
+                <a:solidFill>
+                  <a:srgbClr val="FFC627"/>
+                </a:solidFill>
+              </a:rPr>
+              <a:t>Turning clinical data into patient outcomes</a:t>
+            </a:r>
+          </a:p>
+        </p:txBody>
+      </p:sp>
+      <p:sp>
+        <p:nvSpPr>
+          <p:cNvPr id="7" name="Rectangle 6"/>
+          <p:cNvSpPr/>
+          <p:nvPr/>
+        </p:nvSpPr>
+        <p:spPr>
+          <a:xfrm>
+            <a:off x="365760" y="1188720"/>
+            <a:ext cx="73152" cy="1234440"/>
+          </a:xfrm>
+          <a:prstGeom prst="rect">
+            <a:avLst/>
+          </a:prstGeom>
+          <a:solidFill>
+            <a:srgbClr val="FFC627"/>
+          </a:solidFill>
+          <a:ln>
+            <a:noFill/>
+          </a:ln>
+        </p:spPr>
+        <p:style>
+          <a:lnRef idx="1">
+            <a:schemeClr val="accent1"/>
+          </a:lnRef>
+          <a:fillRef idx="3">
+            <a:schemeClr val="accent1"/>
+          </a:fillRef>
+          <a:effectRef idx="2">
+            <a:schemeClr val="accent1"/>
+          </a:effectRef>
+          <a:fontRef idx="minor">
+            <a:schemeClr val="lt1"/>
+          </a:fontRef>
+        </p:style>
+        <p:txBody>
+          <a:bodyPr rtlCol="0" anchor="ctr"/>
+          <a:lstStyle/>
+          <a:p>
+            <a:pPr algn="ctr"/>
+          </a:p>
+        </p:txBody>
+      </p:sp>
+      <p:sp>
+        <p:nvSpPr>
+          <p:cNvPr id="8" name="TextBox 7"/>
+          <p:cNvSpPr txBox="1"/>
+          <p:nvPr/>
+        </p:nvSpPr>
+        <p:spPr>
+          <a:xfrm>
+            <a:off x="548640" y="1234440"/>
+            <a:ext cx="11183112" cy="384048"/>
+          </a:xfrm>
+          <a:prstGeom prst="rect">
+            <a:avLst/>
+          </a:prstGeom>
+          <a:noFill/>
+        </p:spPr>
+        <p:txBody>
+          <a:bodyPr wrap="none">
+            <a:spAutoFit/>
+          </a:bodyPr>
+          <a:lstStyle/>
+          <a:p>
+            <a:r>
+              <a:rPr sz="1500" b="1">
+                <a:solidFill>
+                  <a:srgbClr val="8C1D40"/>
+                </a:solidFill>
+              </a:rPr>
+              <a:t>🏥  The Problem</a:t>
+            </a:r>
+          </a:p>
+        </p:txBody>
+      </p:sp>
+      <p:sp>
+        <p:nvSpPr>
+          <p:cNvPr id="9" name="TextBox 8"/>
+          <p:cNvSpPr txBox="1"/>
+          <p:nvPr/>
+        </p:nvSpPr>
+        <p:spPr>
+          <a:xfrm>
+            <a:off x="548640" y="1645920"/>
+            <a:ext cx="11183112" cy="713232"/>
+          </a:xfrm>
+          <a:prstGeom prst="rect">
+            <a:avLst/>
+          </a:prstGeom>
+          <a:noFill/>
+        </p:spPr>
+        <p:txBody>
+          <a:bodyPr wrap="square">
+            <a:spAutoFit/>
+          </a:bodyPr>
+          <a:lstStyle/>
+          <a:p>
+            <a:r>
+              <a:rPr sz="1200">
+                <a:solidFill>
+                  <a:srgbClr val="282828"/>
+                </a:solidFill>
+              </a:rPr>
+              <a:t>PT labs collect rich biomechanical data — but patients see charts, not movement. Compliance drops 50% after 2 weeks without engaging feedback.</a:t>
+            </a:r>
+          </a:p>
+        </p:txBody>
+      </p:sp>
+      <p:sp>
+        <p:nvSpPr>
+          <p:cNvPr id="10" name="Rectangle 9"/>
+          <p:cNvSpPr/>
+          <p:nvPr/>
+        </p:nvSpPr>
+        <p:spPr>
+          <a:xfrm>
+            <a:off x="365760" y="2496312"/>
+            <a:ext cx="73152" cy="1234440"/>
+          </a:xfrm>
+          <a:prstGeom prst="rect">
+            <a:avLst/>
+          </a:prstGeom>
+          <a:solidFill>
+            <a:srgbClr val="FFC627"/>
+          </a:solidFill>
+          <a:ln>
+            <a:noFill/>
+          </a:ln>
+        </p:spPr>
+        <p:style>
+          <a:lnRef idx="1">
+            <a:schemeClr val="accent1"/>
+          </a:lnRef>
+          <a:fillRef idx="3">
+            <a:schemeClr val="accent1"/>
+          </a:fillRef>
+          <a:effectRef idx="2">
+            <a:schemeClr val="accent1"/>
+          </a:effectRef>
+          <a:fontRef idx="minor">
+            <a:schemeClr val="lt1"/>
+          </a:fontRef>
+        </p:style>
+        <p:txBody>
+          <a:bodyPr rtlCol="0" anchor="ctr"/>
+          <a:lstStyle/>
+          <a:p>
+            <a:pPr algn="ctr"/>
+          </a:p>
+        </p:txBody>
+      </p:sp>
+      <p:sp>
+        <p:nvSpPr>
+          <p:cNvPr id="11" name="TextBox 10"/>
+          <p:cNvSpPr txBox="1"/>
+          <p:nvPr/>
+        </p:nvSpPr>
+        <p:spPr>
+          <a:xfrm>
+            <a:off x="548640" y="2542032"/>
+            <a:ext cx="11183112" cy="384048"/>
+          </a:xfrm>
+          <a:prstGeom prst="rect">
+            <a:avLst/>
+          </a:prstGeom>
+          <a:noFill/>
+        </p:spPr>
+        <p:txBody>
+          <a:bodyPr wrap="none">
+            <a:spAutoFit/>
+          </a:bodyPr>
+          <a:lstStyle/>
+          <a:p>
+            <a:r>
+              <a:rPr sz="1500" b="1">
+                <a:solidFill>
+                  <a:srgbClr val="8C1D40"/>
+                </a:solidFill>
+              </a:rPr>
+              <a:t>💡  The Solution</a:t>
+            </a:r>
+          </a:p>
+        </p:txBody>
+      </p:sp>
+      <p:sp>
+        <p:nvSpPr>
+          <p:cNvPr id="12" name="TextBox 11"/>
+          <p:cNvSpPr txBox="1"/>
+          <p:nvPr/>
+        </p:nvSpPr>
+        <p:spPr>
+          <a:xfrm>
+            <a:off x="548640" y="2953512"/>
+            <a:ext cx="11183112" cy="713232"/>
+          </a:xfrm>
+          <a:prstGeom prst="rect">
+            <a:avLst/>
+          </a:prstGeom>
+          <a:noFill/>
+        </p:spPr>
+        <p:txBody>
+          <a:bodyPr wrap="square">
+            <a:spAutoFit/>
+          </a:bodyPr>
+          <a:lstStyle/>
+          <a:p>
+            <a:r>
+              <a:rPr sz="1200">
+                <a:solidFill>
+                  <a:srgbClr val="282828"/>
+                </a:solidFill>
+              </a:rPr>
+              <a:t>Convert C3D gait data into a real-time UE5 skeleton. Patients watch their own movement, track ROM week-over-week, and stay engaged.</a:t>
+            </a:r>
+          </a:p>
+        </p:txBody>
+      </p:sp>
+      <p:sp>
+        <p:nvSpPr>
+          <p:cNvPr id="13" name="Rectangle 12"/>
+          <p:cNvSpPr/>
+          <p:nvPr/>
+        </p:nvSpPr>
+        <p:spPr>
+          <a:xfrm>
+            <a:off x="365760" y="3803904"/>
+            <a:ext cx="73152" cy="1234440"/>
+          </a:xfrm>
+          <a:prstGeom prst="rect">
+            <a:avLst/>
+          </a:prstGeom>
+          <a:solidFill>
+            <a:srgbClr val="FFC627"/>
+          </a:solidFill>
+          <a:ln>
+            <a:noFill/>
+          </a:ln>
+        </p:spPr>
+        <p:style>
+          <a:lnRef idx="1">
+            <a:schemeClr val="accent1"/>
+          </a:lnRef>
+          <a:fillRef idx="3">
+            <a:schemeClr val="accent1"/>
+          </a:fillRef>
+          <a:effectRef idx="2">
+            <a:schemeClr val="accent1"/>
+          </a:effectRef>
+          <a:fontRef idx="minor">
+            <a:schemeClr val="lt1"/>
+          </a:fontRef>
+        </p:style>
+        <p:txBody>
+          <a:bodyPr rtlCol="0" anchor="ctr"/>
+          <a:lstStyle/>
+          <a:p>
+            <a:pPr algn="ctr"/>
+          </a:p>
+        </p:txBody>
+      </p:sp>
+      <p:sp>
+        <p:nvSpPr>
+          <p:cNvPr id="14" name="TextBox 13"/>
+          <p:cNvSpPr txBox="1"/>
+          <p:nvPr/>
+        </p:nvSpPr>
+        <p:spPr>
+          <a:xfrm>
+            <a:off x="548640" y="3849624"/>
+            <a:ext cx="11183112" cy="384048"/>
+          </a:xfrm>
+          <a:prstGeom prst="rect">
+            <a:avLst/>
+          </a:prstGeom>
+          <a:noFill/>
+        </p:spPr>
+        <p:txBody>
+          <a:bodyPr wrap="none">
+            <a:spAutoFit/>
+          </a:bodyPr>
+          <a:lstStyle/>
+          <a:p>
+            <a:r>
+              <a:rPr sz="1500" b="1">
+                <a:solidFill>
+                  <a:srgbClr val="8C1D40"/>
+                </a:solidFill>
+              </a:rPr>
+              <a:t>📈  The Impact</a:t>
+            </a:r>
+          </a:p>
+        </p:txBody>
+      </p:sp>
+      <p:sp>
+        <p:nvSpPr>
+          <p:cNvPr id="15" name="TextBox 14"/>
+          <p:cNvSpPr txBox="1"/>
+          <p:nvPr/>
+        </p:nvSpPr>
+        <p:spPr>
+          <a:xfrm>
+            <a:off x="548640" y="4261104"/>
+            <a:ext cx="11183112" cy="713232"/>
+          </a:xfrm>
+          <a:prstGeom prst="rect">
+            <a:avLst/>
+          </a:prstGeom>
+          <a:noFill/>
+        </p:spPr>
+        <p:txBody>
+          <a:bodyPr wrap="square">
+            <a:spAutoFit/>
+          </a:bodyPr>
+          <a:lstStyle/>
+          <a:p>
+            <a:r>
+              <a:rPr sz="1200">
+                <a:solidFill>
+                  <a:srgbClr val="282828"/>
+                </a:solidFill>
+              </a:rPr>
+              <a:t>Gamified visual feedback improves rehabilitation compliance by 30–60%. No new hardware — your Vicon/Nexus lab already captures the data.</a:t>
+            </a:r>
+          </a:p>
+        </p:txBody>
+      </p:sp>
+      <p:sp>
+        <p:nvSpPr>
+          <p:cNvPr id="16" name="Rectangle 15"/>
+          <p:cNvSpPr/>
+          <p:nvPr/>
+        </p:nvSpPr>
+        <p:spPr>
+          <a:xfrm>
+            <a:off x="365760" y="5111496"/>
+            <a:ext cx="73152" cy="1234440"/>
+          </a:xfrm>
+          <a:prstGeom prst="rect">
+            <a:avLst/>
+          </a:prstGeom>
+          <a:solidFill>
+            <a:srgbClr val="FFC627"/>
+          </a:solidFill>
+          <a:ln>
+            <a:noFill/>
+          </a:ln>
+        </p:spPr>
+        <p:style>
+          <a:lnRef idx="1">
+            <a:schemeClr val="accent1"/>
+          </a:lnRef>
+          <a:fillRef idx="3">
+            <a:schemeClr val="accent1"/>
+          </a:fillRef>
+          <a:effectRef idx="2">
+            <a:schemeClr val="accent1"/>
+          </a:effectRef>
+          <a:fontRef idx="minor">
+            <a:schemeClr val="lt1"/>
+          </a:fontRef>
+        </p:style>
+        <p:txBody>
+          <a:bodyPr rtlCol="0" anchor="ctr"/>
+          <a:lstStyle/>
+          <a:p>
+            <a:pPr algn="ctr"/>
+          </a:p>
+        </p:txBody>
+      </p:sp>
+      <p:sp>
+        <p:nvSpPr>
+          <p:cNvPr id="17" name="TextBox 16"/>
+          <p:cNvSpPr txBox="1"/>
+          <p:nvPr/>
+        </p:nvSpPr>
+        <p:spPr>
+          <a:xfrm>
+            <a:off x="548640" y="5157216"/>
+            <a:ext cx="11183112" cy="384048"/>
+          </a:xfrm>
+          <a:prstGeom prst="rect">
+            <a:avLst/>
+          </a:prstGeom>
+          <a:noFill/>
+        </p:spPr>
+        <p:txBody>
+          <a:bodyPr wrap="none">
+            <a:spAutoFit/>
+          </a:bodyPr>
+          <a:lstStyle/>
+          <a:p>
+            <a:r>
+              <a:rPr sz="1500" b="1">
+                <a:solidFill>
+                  <a:srgbClr val="8C1D40"/>
+                </a:solidFill>
+              </a:rPr>
+              <a:t>🎯  The Fit</a:t>
+            </a:r>
+          </a:p>
+        </p:txBody>
+      </p:sp>
+      <p:sp>
+        <p:nvSpPr>
+          <p:cNvPr id="18" name="TextBox 17"/>
+          <p:cNvSpPr txBox="1"/>
+          <p:nvPr/>
+        </p:nvSpPr>
+        <p:spPr>
+          <a:xfrm>
+            <a:off x="548640" y="5568696"/>
+            <a:ext cx="11183112" cy="713232"/>
+          </a:xfrm>
+          <a:prstGeom prst="rect">
+            <a:avLst/>
+          </a:prstGeom>
+          <a:noFill/>
+        </p:spPr>
+        <p:txBody>
+          <a:bodyPr wrap="square">
+            <a:spAutoFit/>
+          </a:bodyPr>
+          <a:lstStyle/>
+          <a:p>
+            <a:r>
+              <a:rPr sz="1200">
+                <a:solidFill>
+                  <a:srgbClr val="282828"/>
+                </a:solidFill>
+              </a:rPr>
+              <a:t>This tool bridges the gap between clinical capture and interactive visualization. Drop-in compatible with existing ASU lab infrastructure.</a:t>
+            </a:r>
+          </a:p>
+        </p:txBody>
+      </p:sp>
+    </p:spTree>
+  </p:cSld>
+  <p:clrMapOvr>
+    <a:masterClrMapping/>
+  </p:clrMapOvr>
+</p:sld>
+</file>
+
+<file path=ppt/slides/slide15.xml><?xml version="1.0" encoding="utf-8"?>
+<p:sld xmlns:a="http://schemas.openxmlformats.org/drawingml/2006/main" xmlns:p="http://schemas.openxmlformats.org/presentationml/2006/main" xmlns:r="http://schemas.openxmlformats.org/officeDocument/2006/relationships">
+  <p:cSld>
+    <p:spTree>
+      <p:nvGrpSpPr>
+        <p:cNvPr id="1" name=""/>
+        <p:cNvGrpSpPr/>
+        <p:nvPr/>
+      </p:nvGrpSpPr>
+      <p:grpSpPr/>
+      <p:sp>
+        <p:nvSpPr>
+          <p:cNvPr id="2" name="Rectangle 1"/>
+          <p:cNvSpPr/>
+          <p:nvPr/>
+        </p:nvSpPr>
+        <p:spPr>
+          <a:xfrm>
+            <a:off x="0" y="0"/>
+            <a:ext cx="12188952" cy="6858000"/>
+          </a:xfrm>
+          <a:prstGeom prst="rect">
+            <a:avLst/>
+          </a:prstGeom>
+          <a:solidFill>
+            <a:srgbClr val="FFFFFF"/>
+          </a:solidFill>
+          <a:ln>
+            <a:noFill/>
+          </a:ln>
+        </p:spPr>
+        <p:style>
+          <a:lnRef idx="1">
+            <a:schemeClr val="accent1"/>
+          </a:lnRef>
+          <a:fillRef idx="3">
+            <a:schemeClr val="accent1"/>
+          </a:fillRef>
+          <a:effectRef idx="2">
+            <a:schemeClr val="accent1"/>
+          </a:effectRef>
+          <a:fontRef idx="minor">
+            <a:schemeClr val="lt1"/>
+          </a:fontRef>
+        </p:style>
+        <p:txBody>
+          <a:bodyPr rtlCol="0" anchor="ctr"/>
+          <a:lstStyle/>
+          <a:p>
+            <a:pPr algn="ctr"/>
+          </a:p>
+        </p:txBody>
+      </p:sp>
+      <p:sp>
+        <p:nvSpPr>
+          <p:cNvPr id="3" name="Rectangle 2"/>
+          <p:cNvSpPr/>
+          <p:nvPr/>
+        </p:nvSpPr>
+        <p:spPr>
+          <a:xfrm>
+            <a:off x="0" y="0"/>
+            <a:ext cx="12188952" cy="1005840"/>
+          </a:xfrm>
+          <a:prstGeom prst="rect">
+            <a:avLst/>
+          </a:prstGeom>
+          <a:solidFill>
+            <a:srgbClr val="8C1D40"/>
+          </a:solidFill>
+          <a:ln>
+            <a:noFill/>
+          </a:ln>
+        </p:spPr>
+        <p:style>
+          <a:lnRef idx="1">
+            <a:schemeClr val="accent1"/>
+          </a:lnRef>
+          <a:fillRef idx="3">
+            <a:schemeClr val="accent1"/>
+          </a:fillRef>
+          <a:effectRef idx="2">
+            <a:schemeClr val="accent1"/>
+          </a:effectRef>
+          <a:fontRef idx="minor">
+            <a:schemeClr val="lt1"/>
+          </a:fontRef>
+        </p:style>
+        <p:txBody>
+          <a:bodyPr rtlCol="0" anchor="ctr"/>
+          <a:lstStyle/>
+          <a:p>
+            <a:pPr algn="ctr"/>
+          </a:p>
+        </p:txBody>
+      </p:sp>
+      <p:sp>
+        <p:nvSpPr>
+          <p:cNvPr id="4" name="Rectangle 3"/>
+          <p:cNvSpPr/>
+          <p:nvPr/>
+        </p:nvSpPr>
+        <p:spPr>
+          <a:xfrm>
+            <a:off x="0" y="1005840"/>
+            <a:ext cx="12188952" cy="64008"/>
+          </a:xfrm>
+          <a:prstGeom prst="rect">
+            <a:avLst/>
+          </a:prstGeom>
+          <a:solidFill>
+            <a:srgbClr val="FFC627"/>
+          </a:solidFill>
+          <a:ln>
+            <a:noFill/>
+          </a:ln>
+        </p:spPr>
+        <p:style>
+          <a:lnRef idx="1">
+            <a:schemeClr val="accent1"/>
+          </a:lnRef>
+          <a:fillRef idx="3">
+            <a:schemeClr val="accent1"/>
+          </a:fillRef>
+          <a:effectRef idx="2">
+            <a:schemeClr val="accent1"/>
+          </a:effectRef>
+          <a:fontRef idx="minor">
+            <a:schemeClr val="lt1"/>
+          </a:fontRef>
+        </p:style>
+        <p:txBody>
+          <a:bodyPr rtlCol="0" anchor="ctr"/>
+          <a:lstStyle/>
+          <a:p>
+            <a:pPr algn="ctr"/>
+          </a:p>
+        </p:txBody>
+      </p:sp>
+      <p:sp>
+        <p:nvSpPr>
+          <p:cNvPr id="5" name="TextBox 4"/>
+          <p:cNvSpPr txBox="1"/>
+          <p:nvPr/>
+        </p:nvSpPr>
+        <p:spPr>
+          <a:xfrm>
+            <a:off x="457200" y="91440"/>
+            <a:ext cx="11274552" cy="502920"/>
+          </a:xfrm>
+          <a:prstGeom prst="rect">
+            <a:avLst/>
+          </a:prstGeom>
+          <a:noFill/>
+        </p:spPr>
+        <p:txBody>
+          <a:bodyPr wrap="none">
+            <a:spAutoFit/>
+          </a:bodyPr>
+          <a:lstStyle/>
+          <a:p>
+            <a:r>
+              <a:rPr sz="3000" b="1">
+                <a:solidFill>
+                  <a:srgbClr val="FFFFFF"/>
+                </a:solidFill>
+              </a:rPr>
+              <a:t>USE CASE: RESEARCH &amp; SPORTS PERFORMANCE</a:t>
+            </a:r>
+          </a:p>
+        </p:txBody>
+      </p:sp>
+      <p:sp>
+        <p:nvSpPr>
+          <p:cNvPr id="6" name="TextBox 5"/>
+          <p:cNvSpPr txBox="1"/>
+          <p:nvPr/>
+        </p:nvSpPr>
+        <p:spPr>
+          <a:xfrm>
+            <a:off x="457200" y="594360"/>
+            <a:ext cx="11274552" cy="320040"/>
+          </a:xfrm>
+          <a:prstGeom prst="rect">
+            <a:avLst/>
+          </a:prstGeom>
+          <a:noFill/>
+        </p:spPr>
+        <p:txBody>
+          <a:bodyPr wrap="none">
+            <a:spAutoFit/>
+          </a:bodyPr>
+          <a:lstStyle/>
+          <a:p>
+            <a:r>
+              <a:rPr sz="1400" b="0">
+                <a:solidFill>
+                  <a:srgbClr val="FFC627"/>
+                </a:solidFill>
+              </a:rPr>
+              <a:t>Making motion data accessible and presentable</a:t>
+            </a:r>
+          </a:p>
+        </p:txBody>
+      </p:sp>
+      <p:sp>
+        <p:nvSpPr>
+          <p:cNvPr id="7" name="Rectangle 6"/>
+          <p:cNvSpPr/>
+          <p:nvPr/>
+        </p:nvSpPr>
+        <p:spPr>
+          <a:xfrm>
+            <a:off x="365760" y="1188720"/>
+            <a:ext cx="73152" cy="1234440"/>
+          </a:xfrm>
+          <a:prstGeom prst="rect">
+            <a:avLst/>
+          </a:prstGeom>
+          <a:solidFill>
+            <a:srgbClr val="FFC627"/>
+          </a:solidFill>
+          <a:ln>
+            <a:noFill/>
+          </a:ln>
+        </p:spPr>
+        <p:style>
+          <a:lnRef idx="1">
+            <a:schemeClr val="accent1"/>
+          </a:lnRef>
+          <a:fillRef idx="3">
+            <a:schemeClr val="accent1"/>
+          </a:fillRef>
+          <a:effectRef idx="2">
+            <a:schemeClr val="accent1"/>
+          </a:effectRef>
+          <a:fontRef idx="minor">
+            <a:schemeClr val="lt1"/>
+          </a:fontRef>
+        </p:style>
+        <p:txBody>
+          <a:bodyPr rtlCol="0" anchor="ctr"/>
+          <a:lstStyle/>
+          <a:p>
+            <a:pPr algn="ctr"/>
+          </a:p>
+        </p:txBody>
+      </p:sp>
+      <p:sp>
+        <p:nvSpPr>
+          <p:cNvPr id="8" name="TextBox 7"/>
+          <p:cNvSpPr txBox="1"/>
+          <p:nvPr/>
+        </p:nvSpPr>
+        <p:spPr>
+          <a:xfrm>
+            <a:off x="548640" y="1234440"/>
+            <a:ext cx="11183112" cy="384048"/>
+          </a:xfrm>
+          <a:prstGeom prst="rect">
+            <a:avLst/>
+          </a:prstGeom>
+          <a:noFill/>
+        </p:spPr>
+        <p:txBody>
+          <a:bodyPr wrap="none">
+            <a:spAutoFit/>
+          </a:bodyPr>
+          <a:lstStyle/>
+          <a:p>
+            <a:r>
+              <a:rPr sz="1500" b="1">
+                <a:solidFill>
+                  <a:srgbClr val="8C1D40"/>
+                </a:solidFill>
+              </a:rPr>
+              <a:t>📦  The Problem</a:t>
+            </a:r>
+          </a:p>
+        </p:txBody>
+      </p:sp>
+      <p:sp>
+        <p:nvSpPr>
+          <p:cNvPr id="9" name="TextBox 8"/>
+          <p:cNvSpPr txBox="1"/>
+          <p:nvPr/>
+        </p:nvSpPr>
+        <p:spPr>
+          <a:xfrm>
+            <a:off x="548640" y="1645920"/>
+            <a:ext cx="11183112" cy="713232"/>
+          </a:xfrm>
+          <a:prstGeom prst="rect">
+            <a:avLst/>
+          </a:prstGeom>
+          <a:noFill/>
+        </p:spPr>
+        <p:txBody>
+          <a:bodyPr wrap="square">
+            <a:spAutoFit/>
+          </a:bodyPr>
+          <a:lstStyle/>
+          <a:p>
+            <a:r>
+              <a:rPr sz="1200">
+                <a:solidFill>
+                  <a:srgbClr val="282828"/>
+                </a:solidFill>
+              </a:rPr>
+              <a:t>Labs have years of archived C3D files sitting unused. Hard to share, hard to present, hard to compare — spreadsheets don't tell the story.</a:t>
+            </a:r>
+          </a:p>
+        </p:txBody>
+      </p:sp>
+      <p:sp>
+        <p:nvSpPr>
+          <p:cNvPr id="10" name="Rectangle 9"/>
+          <p:cNvSpPr/>
+          <p:nvPr/>
+        </p:nvSpPr>
+        <p:spPr>
+          <a:xfrm>
+            <a:off x="365760" y="2496312"/>
+            <a:ext cx="73152" cy="1234440"/>
+          </a:xfrm>
+          <a:prstGeom prst="rect">
+            <a:avLst/>
+          </a:prstGeom>
+          <a:solidFill>
+            <a:srgbClr val="FFC627"/>
+          </a:solidFill>
+          <a:ln>
+            <a:noFill/>
+          </a:ln>
+        </p:spPr>
+        <p:style>
+          <a:lnRef idx="1">
+            <a:schemeClr val="accent1"/>
+          </a:lnRef>
+          <a:fillRef idx="3">
+            <a:schemeClr val="accent1"/>
+          </a:fillRef>
+          <a:effectRef idx="2">
+            <a:schemeClr val="accent1"/>
+          </a:effectRef>
+          <a:fontRef idx="minor">
+            <a:schemeClr val="lt1"/>
+          </a:fontRef>
+        </p:style>
+        <p:txBody>
+          <a:bodyPr rtlCol="0" anchor="ctr"/>
+          <a:lstStyle/>
+          <a:p>
+            <a:pPr algn="ctr"/>
+          </a:p>
+        </p:txBody>
+      </p:sp>
+      <p:sp>
+        <p:nvSpPr>
+          <p:cNvPr id="11" name="TextBox 10"/>
+          <p:cNvSpPr txBox="1"/>
+          <p:nvPr/>
+        </p:nvSpPr>
+        <p:spPr>
+          <a:xfrm>
+            <a:off x="548640" y="2542032"/>
+            <a:ext cx="11183112" cy="384048"/>
+          </a:xfrm>
+          <a:prstGeom prst="rect">
+            <a:avLst/>
+          </a:prstGeom>
+          <a:noFill/>
+        </p:spPr>
+        <p:txBody>
+          <a:bodyPr wrap="none">
+            <a:spAutoFit/>
+          </a:bodyPr>
+          <a:lstStyle/>
+          <a:p>
+            <a:r>
+              <a:rPr sz="1500" b="1">
+                <a:solidFill>
+                  <a:srgbClr val="8C1D40"/>
+                </a:solidFill>
+              </a:rPr>
+              <a:t>💡  The Solution</a:t>
+            </a:r>
+          </a:p>
+        </p:txBody>
+      </p:sp>
+      <p:sp>
+        <p:nvSpPr>
+          <p:cNvPr id="12" name="TextBox 11"/>
+          <p:cNvSpPr txBox="1"/>
+          <p:nvPr/>
+        </p:nvSpPr>
+        <p:spPr>
+          <a:xfrm>
+            <a:off x="548640" y="2953512"/>
+            <a:ext cx="11183112" cy="713232"/>
+          </a:xfrm>
+          <a:prstGeom prst="rect">
+            <a:avLst/>
+          </a:prstGeom>
+          <a:noFill/>
+        </p:spPr>
+        <p:txBody>
+          <a:bodyPr wrap="square">
+            <a:spAutoFit/>
+          </a:bodyPr>
+          <a:lstStyle/>
+          <a:p>
+            <a:r>
+              <a:rPr sz="1200">
+                <a:solidFill>
+                  <a:srgbClr val="282828"/>
+                </a:solidFill>
+              </a:rPr>
+              <a:t>Convert any C3D file into interactive 3D scenes in UE5. Overlay athletes side-by-side, compare gait patterns, visualize asymmetries in real time.</a:t>
+            </a:r>
+          </a:p>
+        </p:txBody>
+      </p:sp>
+      <p:sp>
+        <p:nvSpPr>
+          <p:cNvPr id="13" name="Rectangle 12"/>
+          <p:cNvSpPr/>
+          <p:nvPr/>
+        </p:nvSpPr>
+        <p:spPr>
+          <a:xfrm>
+            <a:off x="365760" y="3803904"/>
+            <a:ext cx="73152" cy="1234440"/>
+          </a:xfrm>
+          <a:prstGeom prst="rect">
+            <a:avLst/>
+          </a:prstGeom>
+          <a:solidFill>
+            <a:srgbClr val="FFC627"/>
+          </a:solidFill>
+          <a:ln>
+            <a:noFill/>
+          </a:ln>
+        </p:spPr>
+        <p:style>
+          <a:lnRef idx="1">
+            <a:schemeClr val="accent1"/>
+          </a:lnRef>
+          <a:fillRef idx="3">
+            <a:schemeClr val="accent1"/>
+          </a:fillRef>
+          <a:effectRef idx="2">
+            <a:schemeClr val="accent1"/>
+          </a:effectRef>
+          <a:fontRef idx="minor">
+            <a:schemeClr val="lt1"/>
+          </a:fontRef>
+        </p:style>
+        <p:txBody>
+          <a:bodyPr rtlCol="0" anchor="ctr"/>
+          <a:lstStyle/>
+          <a:p>
+            <a:pPr algn="ctr"/>
+          </a:p>
+        </p:txBody>
+      </p:sp>
+      <p:sp>
+        <p:nvSpPr>
+          <p:cNvPr id="14" name="TextBox 13"/>
+          <p:cNvSpPr txBox="1"/>
+          <p:nvPr/>
+        </p:nvSpPr>
+        <p:spPr>
+          <a:xfrm>
+            <a:off x="548640" y="3849624"/>
+            <a:ext cx="11183112" cy="384048"/>
+          </a:xfrm>
+          <a:prstGeom prst="rect">
+            <a:avLst/>
+          </a:prstGeom>
+          <a:noFill/>
+        </p:spPr>
+        <p:txBody>
+          <a:bodyPr wrap="none">
+            <a:spAutoFit/>
+          </a:bodyPr>
+          <a:lstStyle/>
+          <a:p>
+            <a:r>
+              <a:rPr sz="1500" b="1">
+                <a:solidFill>
+                  <a:srgbClr val="8C1D40"/>
+                </a:solidFill>
+              </a:rPr>
+              <a:t>🏆  The Impact</a:t>
+            </a:r>
+          </a:p>
+        </p:txBody>
+      </p:sp>
+      <p:sp>
+        <p:nvSpPr>
+          <p:cNvPr id="15" name="TextBox 14"/>
+          <p:cNvSpPr txBox="1"/>
+          <p:nvPr/>
+        </p:nvSpPr>
+        <p:spPr>
+          <a:xfrm>
+            <a:off x="548640" y="4261104"/>
+            <a:ext cx="11183112" cy="713232"/>
+          </a:xfrm>
+          <a:prstGeom prst="rect">
+            <a:avLst/>
+          </a:prstGeom>
+          <a:noFill/>
+        </p:spPr>
+        <p:txBody>
+          <a:bodyPr wrap="square">
+            <a:spAutoFit/>
+          </a:bodyPr>
+          <a:lstStyle/>
+          <a:p>
+            <a:r>
+              <a:rPr sz="1200">
+                <a:solidFill>
+                  <a:srgbClr val="282828"/>
+                </a:solidFill>
+              </a:rPr>
+              <a:t>Bring motion data to life for funding pitches, publications, and conferences. Reviewers and sponsors understand 3D demos — not just p-values.</a:t>
+            </a:r>
+          </a:p>
+        </p:txBody>
+      </p:sp>
+      <p:sp>
+        <p:nvSpPr>
+          <p:cNvPr id="16" name="Rectangle 15"/>
+          <p:cNvSpPr/>
+          <p:nvPr/>
+        </p:nvSpPr>
+        <p:spPr>
+          <a:xfrm>
+            <a:off x="365760" y="5111496"/>
+            <a:ext cx="73152" cy="1234440"/>
+          </a:xfrm>
+          <a:prstGeom prst="rect">
+            <a:avLst/>
+          </a:prstGeom>
+          <a:solidFill>
+            <a:srgbClr val="FFC627"/>
+          </a:solidFill>
+          <a:ln>
+            <a:noFill/>
+          </a:ln>
+        </p:spPr>
+        <p:style>
+          <a:lnRef idx="1">
+            <a:schemeClr val="accent1"/>
+          </a:lnRef>
+          <a:fillRef idx="3">
+            <a:schemeClr val="accent1"/>
+          </a:fillRef>
+          <a:effectRef idx="2">
+            <a:schemeClr val="accent1"/>
+          </a:effectRef>
+          <a:fontRef idx="minor">
+            <a:schemeClr val="lt1"/>
+          </a:fontRef>
+        </p:style>
+        <p:txBody>
+          <a:bodyPr rtlCol="0" anchor="ctr"/>
+          <a:lstStyle/>
+          <a:p>
+            <a:pPr algn="ctr"/>
+          </a:p>
+        </p:txBody>
+      </p:sp>
+      <p:sp>
+        <p:nvSpPr>
+          <p:cNvPr id="17" name="TextBox 16"/>
+          <p:cNvSpPr txBox="1"/>
+          <p:nvPr/>
+        </p:nvSpPr>
+        <p:spPr>
+          <a:xfrm>
+            <a:off x="548640" y="5157216"/>
+            <a:ext cx="11183112" cy="384048"/>
+          </a:xfrm>
+          <a:prstGeom prst="rect">
+            <a:avLst/>
+          </a:prstGeom>
+          <a:noFill/>
+        </p:spPr>
+        <p:txBody>
+          <a:bodyPr wrap="none">
+            <a:spAutoFit/>
+          </a:bodyPr>
+          <a:lstStyle/>
+          <a:p>
+            <a:r>
+              <a:rPr sz="1500" b="1">
+                <a:solidFill>
+                  <a:srgbClr val="8C1D40"/>
+                </a:solidFill>
+              </a:rPr>
+              <a:t>🔬  The Fit</a:t>
+            </a:r>
+          </a:p>
+        </p:txBody>
+      </p:sp>
+      <p:sp>
+        <p:nvSpPr>
+          <p:cNvPr id="18" name="TextBox 17"/>
+          <p:cNvSpPr txBox="1"/>
+          <p:nvPr/>
+        </p:nvSpPr>
+        <p:spPr>
+          <a:xfrm>
+            <a:off x="548640" y="5568696"/>
+            <a:ext cx="11183112" cy="713232"/>
+          </a:xfrm>
+          <a:prstGeom prst="rect">
+            <a:avLst/>
+          </a:prstGeom>
+          <a:noFill/>
+        </p:spPr>
+        <p:txBody>
+          <a:bodyPr wrap="square">
+            <a:spAutoFit/>
+          </a:bodyPr>
+          <a:lstStyle/>
+          <a:p>
+            <a:r>
+              <a:rPr sz="1200">
+                <a:solidFill>
+                  <a:srgbClr val="282828"/>
+                </a:solidFill>
+              </a:rPr>
+              <a:t>Future roadmap: LiDAR scanning + C3D → patient-specific MetaHuman avatars for pre-surgical planning and clinical digital twins.</a:t>
+            </a:r>
+          </a:p>
+        </p:txBody>
+      </p:sp>
+    </p:spTree>
+  </p:cSld>
+  <p:clrMapOvr>
+    <a:masterClrMapping/>
+  </p:clrMapOvr>
+</p:sld>
+</file>
+
 <file path=ppt/slides/slide2.xml><?xml version="1.0" encoding="utf-8"?>
 <p:sld xmlns:a="http://schemas.openxmlformats.org/drawingml/2006/main" xmlns:p="http://schemas.openxmlformats.org/presentationml/2006/main" xmlns:r="http://schemas.openxmlformats.org/officeDocument/2006/relationships">
   <p:cSld>
@@ -7958,1066 +9256,6 @@
                 </a:solidFill>
               </a:rPr>
               <a:t>Key innovation: Mixamo-named skeleton output → drops directly into UE5 / Unity retargeting with ZERO manual rigging</a:t>
-            </a:r>
-          </a:p>
-        </p:txBody>
-      </p:sp>
-    </p:spTree>
-  </p:cSld>
-  <p:clrMapOvr>
-    <a:masterClrMapping/>
-  </p:clrMapOvr>
-</p:sld>
-</file>
-
-<file path=ppt/slides/slide4.xml><?xml version="1.0" encoding="utf-8"?>
-<p:sld xmlns:a="http://schemas.openxmlformats.org/drawingml/2006/main" xmlns:p="http://schemas.openxmlformats.org/presentationml/2006/main" xmlns:r="http://schemas.openxmlformats.org/officeDocument/2006/relationships">
-  <p:cSld>
-    <p:spTree>
-      <p:nvGrpSpPr>
-        <p:cNvPr id="1" name=""/>
-        <p:cNvGrpSpPr/>
-        <p:nvPr/>
-      </p:nvGrpSpPr>
-      <p:grpSpPr/>
-      <p:sp>
-        <p:nvSpPr>
-          <p:cNvPr id="2" name="Rectangle 1"/>
-          <p:cNvSpPr/>
-          <p:nvPr/>
-        </p:nvSpPr>
-        <p:spPr>
-          <a:xfrm>
-            <a:off x="0" y="0"/>
-            <a:ext cx="12188952" cy="914400"/>
-          </a:xfrm>
-          <a:prstGeom prst="rect">
-            <a:avLst/>
-          </a:prstGeom>
-          <a:solidFill>
-            <a:srgbClr val="1F4E79"/>
-          </a:solidFill>
-          <a:ln>
-            <a:noFill/>
-          </a:ln>
-        </p:spPr>
-        <p:style>
-          <a:lnRef idx="1">
-            <a:schemeClr val="accent1"/>
-          </a:lnRef>
-          <a:fillRef idx="3">
-            <a:schemeClr val="accent1"/>
-          </a:fillRef>
-          <a:effectRef idx="2">
-            <a:schemeClr val="accent1"/>
-          </a:effectRef>
-          <a:fontRef idx="minor">
-            <a:schemeClr val="lt1"/>
-          </a:fontRef>
-        </p:style>
-        <p:txBody>
-          <a:bodyPr rtlCol="0" anchor="ctr"/>
-          <a:lstStyle/>
-          <a:p>
-            <a:pPr algn="ctr"/>
-          </a:p>
-        </p:txBody>
-      </p:sp>
-      <p:sp>
-        <p:nvSpPr>
-          <p:cNvPr id="3" name="TextBox 2"/>
-          <p:cNvSpPr txBox="1"/>
-          <p:nvPr/>
-        </p:nvSpPr>
-        <p:spPr>
-          <a:xfrm>
-            <a:off x="457200" y="91440"/>
-            <a:ext cx="11274552" cy="731520"/>
-          </a:xfrm>
-          <a:prstGeom prst="rect">
-            <a:avLst/>
-          </a:prstGeom>
-          <a:noFill/>
-        </p:spPr>
-        <p:txBody>
-          <a:bodyPr wrap="none">
-            <a:spAutoFit/>
-          </a:bodyPr>
-          <a:lstStyle/>
-          <a:p>
-            <a:r>
-              <a:rPr sz="3400" b="1">
-                <a:solidFill>
-                  <a:srgbClr val="FFFFFF"/>
-                </a:solidFill>
-              </a:rPr>
-              <a:t>USE CASE: PHYSICAL THERAPY</a:t>
-            </a:r>
-          </a:p>
-        </p:txBody>
-      </p:sp>
-      <p:sp>
-        <p:nvSpPr>
-          <p:cNvPr id="4" name="Rectangle 3"/>
-          <p:cNvSpPr/>
-          <p:nvPr/>
-        </p:nvSpPr>
-        <p:spPr>
-          <a:xfrm>
-            <a:off x="365760" y="1005840"/>
-            <a:ext cx="11457432" cy="1234440"/>
-          </a:xfrm>
-          <a:prstGeom prst="rect">
-            <a:avLst/>
-          </a:prstGeom>
-          <a:solidFill>
-            <a:srgbClr val="142341"/>
-          </a:solidFill>
-          <a:ln>
-            <a:noFill/>
-          </a:ln>
-        </p:spPr>
-        <p:style>
-          <a:lnRef idx="1">
-            <a:schemeClr val="accent1"/>
-          </a:lnRef>
-          <a:fillRef idx="3">
-            <a:schemeClr val="accent1"/>
-          </a:fillRef>
-          <a:effectRef idx="2">
-            <a:schemeClr val="accent1"/>
-          </a:effectRef>
-          <a:fontRef idx="minor">
-            <a:schemeClr val="lt1"/>
-          </a:fontRef>
-        </p:style>
-        <p:txBody>
-          <a:bodyPr rtlCol="0" anchor="ctr"/>
-          <a:lstStyle/>
-          <a:p>
-            <a:pPr algn="ctr"/>
-          </a:p>
-        </p:txBody>
-      </p:sp>
-      <p:sp>
-        <p:nvSpPr>
-          <p:cNvPr id="5" name="TextBox 4"/>
-          <p:cNvSpPr txBox="1"/>
-          <p:nvPr/>
-        </p:nvSpPr>
-        <p:spPr>
-          <a:xfrm>
-            <a:off x="594360" y="1051560"/>
-            <a:ext cx="5029200" cy="411480"/>
-          </a:xfrm>
-          <a:prstGeom prst="rect">
-            <a:avLst/>
-          </a:prstGeom>
-          <a:noFill/>
-        </p:spPr>
-        <p:txBody>
-          <a:bodyPr wrap="none">
-            <a:spAutoFit/>
-          </a:bodyPr>
-          <a:lstStyle/>
-          <a:p>
-            <a:r>
-              <a:rPr sz="1500" b="1">
-                <a:solidFill>
-                  <a:srgbClr val="DC6400"/>
-                </a:solidFill>
-              </a:rPr>
-              <a:t>❶  Patient sees their own skeleton</a:t>
-            </a:r>
-          </a:p>
-        </p:txBody>
-      </p:sp>
-      <p:sp>
-        <p:nvSpPr>
-          <p:cNvPr id="6" name="TextBox 5"/>
-          <p:cNvSpPr txBox="1"/>
-          <p:nvPr/>
-        </p:nvSpPr>
-        <p:spPr>
-          <a:xfrm>
-            <a:off x="594360" y="1463040"/>
-            <a:ext cx="10908792" cy="685800"/>
-          </a:xfrm>
-          <a:prstGeom prst="rect">
-            <a:avLst/>
-          </a:prstGeom>
-          <a:noFill/>
-        </p:spPr>
-        <p:txBody>
-          <a:bodyPr wrap="square">
-            <a:spAutoFit/>
-          </a:bodyPr>
-          <a:lstStyle/>
-          <a:p>
-            <a:r>
-              <a:rPr sz="1200">
-                <a:solidFill>
-                  <a:srgbClr val="BED2EB"/>
-                </a:solidFill>
-              </a:rPr>
-              <a:t>Capture motion during therapy → visualize real-time in Unreal Engine. No guesswork — patients see exactly how they move.</a:t>
-            </a:r>
-          </a:p>
-        </p:txBody>
-      </p:sp>
-      <p:sp>
-        <p:nvSpPr>
-          <p:cNvPr id="7" name="Rectangle 6"/>
-          <p:cNvSpPr/>
-          <p:nvPr/>
-        </p:nvSpPr>
-        <p:spPr>
-          <a:xfrm>
-            <a:off x="365760" y="2286000"/>
-            <a:ext cx="11457432" cy="1234440"/>
-          </a:xfrm>
-          <a:prstGeom prst="rect">
-            <a:avLst/>
-          </a:prstGeom>
-          <a:solidFill>
-            <a:srgbClr val="142341"/>
-          </a:solidFill>
-          <a:ln>
-            <a:noFill/>
-          </a:ln>
-        </p:spPr>
-        <p:style>
-          <a:lnRef idx="1">
-            <a:schemeClr val="accent1"/>
-          </a:lnRef>
-          <a:fillRef idx="3">
-            <a:schemeClr val="accent1"/>
-          </a:fillRef>
-          <a:effectRef idx="2">
-            <a:schemeClr val="accent1"/>
-          </a:effectRef>
-          <a:fontRef idx="minor">
-            <a:schemeClr val="lt1"/>
-          </a:fontRef>
-        </p:style>
-        <p:txBody>
-          <a:bodyPr rtlCol="0" anchor="ctr"/>
-          <a:lstStyle/>
-          <a:p>
-            <a:pPr algn="ctr"/>
-          </a:p>
-        </p:txBody>
-      </p:sp>
-      <p:sp>
-        <p:nvSpPr>
-          <p:cNvPr id="8" name="TextBox 7"/>
-          <p:cNvSpPr txBox="1"/>
-          <p:nvPr/>
-        </p:nvSpPr>
-        <p:spPr>
-          <a:xfrm>
-            <a:off x="594360" y="2331720"/>
-            <a:ext cx="5029200" cy="411480"/>
-          </a:xfrm>
-          <a:prstGeom prst="rect">
-            <a:avLst/>
-          </a:prstGeom>
-          <a:noFill/>
-        </p:spPr>
-        <p:txBody>
-          <a:bodyPr wrap="none">
-            <a:spAutoFit/>
-          </a:bodyPr>
-          <a:lstStyle/>
-          <a:p>
-            <a:r>
-              <a:rPr sz="1500" b="1">
-                <a:solidFill>
-                  <a:srgbClr val="DC6400"/>
-                </a:solidFill>
-              </a:rPr>
-              <a:t>❷  Objective progress tracking</a:t>
-            </a:r>
-          </a:p>
-        </p:txBody>
-      </p:sp>
-      <p:sp>
-        <p:nvSpPr>
-          <p:cNvPr id="9" name="TextBox 8"/>
-          <p:cNvSpPr txBox="1"/>
-          <p:nvPr/>
-        </p:nvSpPr>
-        <p:spPr>
-          <a:xfrm>
-            <a:off x="594360" y="2743200"/>
-            <a:ext cx="10908792" cy="685800"/>
-          </a:xfrm>
-          <a:prstGeom prst="rect">
-            <a:avLst/>
-          </a:prstGeom>
-          <a:noFill/>
-        </p:spPr>
-        <p:txBody>
-          <a:bodyPr wrap="square">
-            <a:spAutoFit/>
-          </a:bodyPr>
-          <a:lstStyle/>
-          <a:p>
-            <a:r>
-              <a:rPr sz="1200">
-                <a:solidFill>
-                  <a:srgbClr val="BED2EB"/>
-                </a:solidFill>
-              </a:rPr>
-              <a:t>Week-over-week gait comparison using actual clinical C3D data. PTs replace subjective notes with quantified biomechanics.</a:t>
-            </a:r>
-          </a:p>
-        </p:txBody>
-      </p:sp>
-      <p:sp>
-        <p:nvSpPr>
-          <p:cNvPr id="10" name="Rectangle 9"/>
-          <p:cNvSpPr/>
-          <p:nvPr/>
-        </p:nvSpPr>
-        <p:spPr>
-          <a:xfrm>
-            <a:off x="365760" y="3566160"/>
-            <a:ext cx="11457432" cy="1234440"/>
-          </a:xfrm>
-          <a:prstGeom prst="rect">
-            <a:avLst/>
-          </a:prstGeom>
-          <a:solidFill>
-            <a:srgbClr val="142341"/>
-          </a:solidFill>
-          <a:ln>
-            <a:noFill/>
-          </a:ln>
-        </p:spPr>
-        <p:style>
-          <a:lnRef idx="1">
-            <a:schemeClr val="accent1"/>
-          </a:lnRef>
-          <a:fillRef idx="3">
-            <a:schemeClr val="accent1"/>
-          </a:fillRef>
-          <a:effectRef idx="2">
-            <a:schemeClr val="accent1"/>
-          </a:effectRef>
-          <a:fontRef idx="minor">
-            <a:schemeClr val="lt1"/>
-          </a:fontRef>
-        </p:style>
-        <p:txBody>
-          <a:bodyPr rtlCol="0" anchor="ctr"/>
-          <a:lstStyle/>
-          <a:p>
-            <a:pPr algn="ctr"/>
-          </a:p>
-        </p:txBody>
-      </p:sp>
-      <p:sp>
-        <p:nvSpPr>
-          <p:cNvPr id="11" name="TextBox 10"/>
-          <p:cNvSpPr txBox="1"/>
-          <p:nvPr/>
-        </p:nvSpPr>
-        <p:spPr>
-          <a:xfrm>
-            <a:off x="594360" y="3611880"/>
-            <a:ext cx="5029200" cy="411480"/>
-          </a:xfrm>
-          <a:prstGeom prst="rect">
-            <a:avLst/>
-          </a:prstGeom>
-          <a:noFill/>
-        </p:spPr>
-        <p:txBody>
-          <a:bodyPr wrap="none">
-            <a:spAutoFit/>
-          </a:bodyPr>
-          <a:lstStyle/>
-          <a:p>
-            <a:r>
-              <a:rPr sz="1500" b="1">
-                <a:solidFill>
-                  <a:srgbClr val="DC6400"/>
-                </a:solidFill>
-              </a:rPr>
-              <a:t>❸  Gamified recovery</a:t>
-            </a:r>
-          </a:p>
-        </p:txBody>
-      </p:sp>
-      <p:sp>
-        <p:nvSpPr>
-          <p:cNvPr id="12" name="TextBox 11"/>
-          <p:cNvSpPr txBox="1"/>
-          <p:nvPr/>
-        </p:nvSpPr>
-        <p:spPr>
-          <a:xfrm>
-            <a:off x="594360" y="4023360"/>
-            <a:ext cx="10908792" cy="685800"/>
-          </a:xfrm>
-          <a:prstGeom prst="rect">
-            <a:avLst/>
-          </a:prstGeom>
-          <a:noFill/>
-        </p:spPr>
-        <p:txBody>
-          <a:bodyPr wrap="square">
-            <a:spAutoFit/>
-          </a:bodyPr>
-          <a:lstStyle/>
-          <a:p>
-            <a:r>
-              <a:rPr sz="1200">
-                <a:solidFill>
-                  <a:srgbClr val="BED2EB"/>
-                </a:solidFill>
-              </a:rPr>
-              <a:t>Compliance improves 30-60% with visual feedback. Patients stay engaged because they can see improvement — not just feel it.</a:t>
-            </a:r>
-          </a:p>
-        </p:txBody>
-      </p:sp>
-      <p:sp>
-        <p:nvSpPr>
-          <p:cNvPr id="13" name="Rectangle 12"/>
-          <p:cNvSpPr/>
-          <p:nvPr/>
-        </p:nvSpPr>
-        <p:spPr>
-          <a:xfrm>
-            <a:off x="365760" y="4846320"/>
-            <a:ext cx="11457432" cy="1234440"/>
-          </a:xfrm>
-          <a:prstGeom prst="rect">
-            <a:avLst/>
-          </a:prstGeom>
-          <a:solidFill>
-            <a:srgbClr val="142341"/>
-          </a:solidFill>
-          <a:ln>
-            <a:noFill/>
-          </a:ln>
-        </p:spPr>
-        <p:style>
-          <a:lnRef idx="1">
-            <a:schemeClr val="accent1"/>
-          </a:lnRef>
-          <a:fillRef idx="3">
-            <a:schemeClr val="accent1"/>
-          </a:fillRef>
-          <a:effectRef idx="2">
-            <a:schemeClr val="accent1"/>
-          </a:effectRef>
-          <a:fontRef idx="minor">
-            <a:schemeClr val="lt1"/>
-          </a:fontRef>
-        </p:style>
-        <p:txBody>
-          <a:bodyPr rtlCol="0" anchor="ctr"/>
-          <a:lstStyle/>
-          <a:p>
-            <a:pPr algn="ctr"/>
-          </a:p>
-        </p:txBody>
-      </p:sp>
-      <p:sp>
-        <p:nvSpPr>
-          <p:cNvPr id="14" name="TextBox 13"/>
-          <p:cNvSpPr txBox="1"/>
-          <p:nvPr/>
-        </p:nvSpPr>
-        <p:spPr>
-          <a:xfrm>
-            <a:off x="594360" y="4892040"/>
-            <a:ext cx="5029200" cy="411480"/>
-          </a:xfrm>
-          <a:prstGeom prst="rect">
-            <a:avLst/>
-          </a:prstGeom>
-          <a:noFill/>
-        </p:spPr>
-        <p:txBody>
-          <a:bodyPr wrap="none">
-            <a:spAutoFit/>
-          </a:bodyPr>
-          <a:lstStyle/>
-          <a:p>
-            <a:r>
-              <a:rPr sz="1500" b="1">
-                <a:solidFill>
-                  <a:srgbClr val="DC6400"/>
-                </a:solidFill>
-              </a:rPr>
-              <a:t>❹  No new hardware required</a:t>
-            </a:r>
-          </a:p>
-        </p:txBody>
-      </p:sp>
-      <p:sp>
-        <p:nvSpPr>
-          <p:cNvPr id="15" name="TextBox 14"/>
-          <p:cNvSpPr txBox="1"/>
-          <p:nvPr/>
-        </p:nvSpPr>
-        <p:spPr>
-          <a:xfrm>
-            <a:off x="594360" y="5303520"/>
-            <a:ext cx="10908792" cy="685800"/>
-          </a:xfrm>
-          <a:prstGeom prst="rect">
-            <a:avLst/>
-          </a:prstGeom>
-          <a:noFill/>
-        </p:spPr>
-        <p:txBody>
-          <a:bodyPr wrap="square">
-            <a:spAutoFit/>
-          </a:bodyPr>
-          <a:lstStyle/>
-          <a:p>
-            <a:r>
-              <a:rPr sz="1200">
-                <a:solidFill>
-                  <a:srgbClr val="BED2EB"/>
-                </a:solidFill>
-              </a:rPr>
-              <a:t>Your Vicon/Nexus lab already captures the data. This tool bridges the gap to interactive visualization at zero hardware cost.</a:t>
-            </a:r>
-          </a:p>
-        </p:txBody>
-      </p:sp>
-    </p:spTree>
-  </p:cSld>
-  <p:clrMapOvr>
-    <a:masterClrMapping/>
-  </p:clrMapOvr>
-</p:sld>
-</file>
-
-<file path=ppt/slides/slide5.xml><?xml version="1.0" encoding="utf-8"?>
-<p:sld xmlns:a="http://schemas.openxmlformats.org/drawingml/2006/main" xmlns:p="http://schemas.openxmlformats.org/presentationml/2006/main" xmlns:r="http://schemas.openxmlformats.org/officeDocument/2006/relationships">
-  <p:cSld>
-    <p:spTree>
-      <p:nvGrpSpPr>
-        <p:cNvPr id="1" name=""/>
-        <p:cNvGrpSpPr/>
-        <p:nvPr/>
-      </p:nvGrpSpPr>
-      <p:grpSpPr/>
-      <p:sp>
-        <p:nvSpPr>
-          <p:cNvPr id="2" name="Rectangle 1"/>
-          <p:cNvSpPr/>
-          <p:nvPr/>
-        </p:nvSpPr>
-        <p:spPr>
-          <a:xfrm>
-            <a:off x="0" y="0"/>
-            <a:ext cx="12188952" cy="914400"/>
-          </a:xfrm>
-          <a:prstGeom prst="rect">
-            <a:avLst/>
-          </a:prstGeom>
-          <a:solidFill>
-            <a:srgbClr val="1F4E79"/>
-          </a:solidFill>
-          <a:ln>
-            <a:noFill/>
-          </a:ln>
-        </p:spPr>
-        <p:style>
-          <a:lnRef idx="1">
-            <a:schemeClr val="accent1"/>
-          </a:lnRef>
-          <a:fillRef idx="3">
-            <a:schemeClr val="accent1"/>
-          </a:fillRef>
-          <a:effectRef idx="2">
-            <a:schemeClr val="accent1"/>
-          </a:effectRef>
-          <a:fontRef idx="minor">
-            <a:schemeClr val="lt1"/>
-          </a:fontRef>
-        </p:style>
-        <p:txBody>
-          <a:bodyPr rtlCol="0" anchor="ctr"/>
-          <a:lstStyle/>
-          <a:p>
-            <a:pPr algn="ctr"/>
-          </a:p>
-        </p:txBody>
-      </p:sp>
-      <p:sp>
-        <p:nvSpPr>
-          <p:cNvPr id="3" name="TextBox 2"/>
-          <p:cNvSpPr txBox="1"/>
-          <p:nvPr/>
-        </p:nvSpPr>
-        <p:spPr>
-          <a:xfrm>
-            <a:off x="457200" y="91440"/>
-            <a:ext cx="11274552" cy="731520"/>
-          </a:xfrm>
-          <a:prstGeom prst="rect">
-            <a:avLst/>
-          </a:prstGeom>
-          <a:noFill/>
-        </p:spPr>
-        <p:txBody>
-          <a:bodyPr wrap="none">
-            <a:spAutoFit/>
-          </a:bodyPr>
-          <a:lstStyle/>
-          <a:p>
-            <a:r>
-              <a:rPr sz="3400" b="1">
-                <a:solidFill>
-                  <a:srgbClr val="FFFFFF"/>
-                </a:solidFill>
-              </a:rPr>
-              <a:t>USE CASE: RESEARCH &amp; SPORTS PERFORMANCE</a:t>
-            </a:r>
-          </a:p>
-        </p:txBody>
-      </p:sp>
-      <p:sp>
-        <p:nvSpPr>
-          <p:cNvPr id="4" name="Rectangle 3"/>
-          <p:cNvSpPr/>
-          <p:nvPr/>
-        </p:nvSpPr>
-        <p:spPr>
-          <a:xfrm>
-            <a:off x="365760" y="1005840"/>
-            <a:ext cx="11457432" cy="1234440"/>
-          </a:xfrm>
-          <a:prstGeom prst="rect">
-            <a:avLst/>
-          </a:prstGeom>
-          <a:solidFill>
-            <a:srgbClr val="142341"/>
-          </a:solidFill>
-          <a:ln>
-            <a:noFill/>
-          </a:ln>
-        </p:spPr>
-        <p:style>
-          <a:lnRef idx="1">
-            <a:schemeClr val="accent1"/>
-          </a:lnRef>
-          <a:fillRef idx="3">
-            <a:schemeClr val="accent1"/>
-          </a:fillRef>
-          <a:effectRef idx="2">
-            <a:schemeClr val="accent1"/>
-          </a:effectRef>
-          <a:fontRef idx="minor">
-            <a:schemeClr val="lt1"/>
-          </a:fontRef>
-        </p:style>
-        <p:txBody>
-          <a:bodyPr rtlCol="0" anchor="ctr"/>
-          <a:lstStyle/>
-          <a:p>
-            <a:pPr algn="ctr"/>
-          </a:p>
-        </p:txBody>
-      </p:sp>
-      <p:sp>
-        <p:nvSpPr>
-          <p:cNvPr id="5" name="TextBox 4"/>
-          <p:cNvSpPr txBox="1"/>
-          <p:nvPr/>
-        </p:nvSpPr>
-        <p:spPr>
-          <a:xfrm>
-            <a:off x="594360" y="1051560"/>
-            <a:ext cx="5029200" cy="411480"/>
-          </a:xfrm>
-          <a:prstGeom prst="rect">
-            <a:avLst/>
-          </a:prstGeom>
-          <a:noFill/>
-        </p:spPr>
-        <p:txBody>
-          <a:bodyPr wrap="none">
-            <a:spAutoFit/>
-          </a:bodyPr>
-          <a:lstStyle/>
-          <a:p>
-            <a:r>
-              <a:rPr sz="1500" b="1">
-                <a:solidFill>
-                  <a:srgbClr val="DC6400"/>
-                </a:solidFill>
-              </a:rPr>
-              <a:t>❶  Unlock years of archived data</a:t>
-            </a:r>
-          </a:p>
-        </p:txBody>
-      </p:sp>
-      <p:sp>
-        <p:nvSpPr>
-          <p:cNvPr id="6" name="TextBox 5"/>
-          <p:cNvSpPr txBox="1"/>
-          <p:nvPr/>
-        </p:nvSpPr>
-        <p:spPr>
-          <a:xfrm>
-            <a:off x="594360" y="1463040"/>
-            <a:ext cx="10908792" cy="685800"/>
-          </a:xfrm>
-          <a:prstGeom prst="rect">
-            <a:avLst/>
-          </a:prstGeom>
-          <a:noFill/>
-        </p:spPr>
-        <p:txBody>
-          <a:bodyPr wrap="square">
-            <a:spAutoFit/>
-          </a:bodyPr>
-          <a:lstStyle/>
-          <a:p>
-            <a:r>
-              <a:rPr sz="1200">
-                <a:solidFill>
-                  <a:srgbClr val="BED2EB"/>
-                </a:solidFill>
-              </a:rPr>
-              <a:t>Labs have terabytes of C3D files sitting unused. Convert them into interactive 3D scenes — no re-collection needed.</a:t>
-            </a:r>
-          </a:p>
-        </p:txBody>
-      </p:sp>
-      <p:sp>
-        <p:nvSpPr>
-          <p:cNvPr id="7" name="Rectangle 6"/>
-          <p:cNvSpPr/>
-          <p:nvPr/>
-        </p:nvSpPr>
-        <p:spPr>
-          <a:xfrm>
-            <a:off x="365760" y="2286000"/>
-            <a:ext cx="11457432" cy="1234440"/>
-          </a:xfrm>
-          <a:prstGeom prst="rect">
-            <a:avLst/>
-          </a:prstGeom>
-          <a:solidFill>
-            <a:srgbClr val="142341"/>
-          </a:solidFill>
-          <a:ln>
-            <a:noFill/>
-          </a:ln>
-        </p:spPr>
-        <p:style>
-          <a:lnRef idx="1">
-            <a:schemeClr val="accent1"/>
-          </a:lnRef>
-          <a:fillRef idx="3">
-            <a:schemeClr val="accent1"/>
-          </a:fillRef>
-          <a:effectRef idx="2">
-            <a:schemeClr val="accent1"/>
-          </a:effectRef>
-          <a:fontRef idx="minor">
-            <a:schemeClr val="lt1"/>
-          </a:fontRef>
-        </p:style>
-        <p:txBody>
-          <a:bodyPr rtlCol="0" anchor="ctr"/>
-          <a:lstStyle/>
-          <a:p>
-            <a:pPr algn="ctr"/>
-          </a:p>
-        </p:txBody>
-      </p:sp>
-      <p:sp>
-        <p:nvSpPr>
-          <p:cNvPr id="8" name="TextBox 7"/>
-          <p:cNvSpPr txBox="1"/>
-          <p:nvPr/>
-        </p:nvSpPr>
-        <p:spPr>
-          <a:xfrm>
-            <a:off x="594360" y="2331720"/>
-            <a:ext cx="5029200" cy="411480"/>
-          </a:xfrm>
-          <a:prstGeom prst="rect">
-            <a:avLst/>
-          </a:prstGeom>
-          <a:noFill/>
-        </p:spPr>
-        <p:txBody>
-          <a:bodyPr wrap="none">
-            <a:spAutoFit/>
-          </a:bodyPr>
-          <a:lstStyle/>
-          <a:p>
-            <a:r>
-              <a:rPr sz="1500" b="1">
-                <a:solidFill>
-                  <a:srgbClr val="DC6400"/>
-                </a:solidFill>
-              </a:rPr>
-              <a:t>❷  Side-by-side athlete comparison</a:t>
-            </a:r>
-          </a:p>
-        </p:txBody>
-      </p:sp>
-      <p:sp>
-        <p:nvSpPr>
-          <p:cNvPr id="9" name="TextBox 8"/>
-          <p:cNvSpPr txBox="1"/>
-          <p:nvPr/>
-        </p:nvSpPr>
-        <p:spPr>
-          <a:xfrm>
-            <a:off x="594360" y="2743200"/>
-            <a:ext cx="10908792" cy="685800"/>
-          </a:xfrm>
-          <a:prstGeom prst="rect">
-            <a:avLst/>
-          </a:prstGeom>
-          <a:noFill/>
-        </p:spPr>
-        <p:txBody>
-          <a:bodyPr wrap="square">
-            <a:spAutoFit/>
-          </a:bodyPr>
-          <a:lstStyle/>
-          <a:p>
-            <a:r>
-              <a:rPr sz="1200">
-                <a:solidFill>
-                  <a:srgbClr val="BED2EB"/>
-                </a:solidFill>
-              </a:rPr>
-              <a:t>Overlay two skeletons in UE5 to compare gait patterns, ROM, and asymmetries. Instantly visual for coaches and clinicians.</a:t>
-            </a:r>
-          </a:p>
-        </p:txBody>
-      </p:sp>
-      <p:sp>
-        <p:nvSpPr>
-          <p:cNvPr id="10" name="Rectangle 9"/>
-          <p:cNvSpPr/>
-          <p:nvPr/>
-        </p:nvSpPr>
-        <p:spPr>
-          <a:xfrm>
-            <a:off x="365760" y="3566160"/>
-            <a:ext cx="11457432" cy="1234440"/>
-          </a:xfrm>
-          <a:prstGeom prst="rect">
-            <a:avLst/>
-          </a:prstGeom>
-          <a:solidFill>
-            <a:srgbClr val="142341"/>
-          </a:solidFill>
-          <a:ln>
-            <a:noFill/>
-          </a:ln>
-        </p:spPr>
-        <p:style>
-          <a:lnRef idx="1">
-            <a:schemeClr val="accent1"/>
-          </a:lnRef>
-          <a:fillRef idx="3">
-            <a:schemeClr val="accent1"/>
-          </a:fillRef>
-          <a:effectRef idx="2">
-            <a:schemeClr val="accent1"/>
-          </a:effectRef>
-          <a:fontRef idx="minor">
-            <a:schemeClr val="lt1"/>
-          </a:fontRef>
-        </p:style>
-        <p:txBody>
-          <a:bodyPr rtlCol="0" anchor="ctr"/>
-          <a:lstStyle/>
-          <a:p>
-            <a:pPr algn="ctr"/>
-          </a:p>
-        </p:txBody>
-      </p:sp>
-      <p:sp>
-        <p:nvSpPr>
-          <p:cNvPr id="11" name="TextBox 10"/>
-          <p:cNvSpPr txBox="1"/>
-          <p:nvPr/>
-        </p:nvSpPr>
-        <p:spPr>
-          <a:xfrm>
-            <a:off x="594360" y="3611880"/>
-            <a:ext cx="5029200" cy="411480"/>
-          </a:xfrm>
-          <a:prstGeom prst="rect">
-            <a:avLst/>
-          </a:prstGeom>
-          <a:noFill/>
-        </p:spPr>
-        <p:txBody>
-          <a:bodyPr wrap="none">
-            <a:spAutoFit/>
-          </a:bodyPr>
-          <a:lstStyle/>
-          <a:p>
-            <a:r>
-              <a:rPr sz="1500" b="1">
-                <a:solidFill>
-                  <a:srgbClr val="DC6400"/>
-                </a:solidFill>
-              </a:rPr>
-              <a:t>❸  Conference-ready presentations</a:t>
-            </a:r>
-          </a:p>
-        </p:txBody>
-      </p:sp>
-      <p:sp>
-        <p:nvSpPr>
-          <p:cNvPr id="12" name="TextBox 11"/>
-          <p:cNvSpPr txBox="1"/>
-          <p:nvPr/>
-        </p:nvSpPr>
-        <p:spPr>
-          <a:xfrm>
-            <a:off x="594360" y="4023360"/>
-            <a:ext cx="10908792" cy="685800"/>
-          </a:xfrm>
-          <a:prstGeom prst="rect">
-            <a:avLst/>
-          </a:prstGeom>
-          <a:noFill/>
-        </p:spPr>
-        <p:txBody>
-          <a:bodyPr wrap="square">
-            <a:spAutoFit/>
-          </a:bodyPr>
-          <a:lstStyle/>
-          <a:p>
-            <a:r>
-              <a:rPr sz="1200">
-                <a:solidFill>
-                  <a:srgbClr val="BED2EB"/>
-                </a:solidFill>
-              </a:rPr>
-              <a:t>Bring your motion data to life for funding pitches, publications, and academic conferences with real-time 3D demos.</a:t>
-            </a:r>
-          </a:p>
-        </p:txBody>
-      </p:sp>
-      <p:sp>
-        <p:nvSpPr>
-          <p:cNvPr id="13" name="Rectangle 12"/>
-          <p:cNvSpPr/>
-          <p:nvPr/>
-        </p:nvSpPr>
-        <p:spPr>
-          <a:xfrm>
-            <a:off x="365760" y="4846320"/>
-            <a:ext cx="11457432" cy="1234440"/>
-          </a:xfrm>
-          <a:prstGeom prst="rect">
-            <a:avLst/>
-          </a:prstGeom>
-          <a:solidFill>
-            <a:srgbClr val="142341"/>
-          </a:solidFill>
-          <a:ln>
-            <a:noFill/>
-          </a:ln>
-        </p:spPr>
-        <p:style>
-          <a:lnRef idx="1">
-            <a:schemeClr val="accent1"/>
-          </a:lnRef>
-          <a:fillRef idx="3">
-            <a:schemeClr val="accent1"/>
-          </a:fillRef>
-          <a:effectRef idx="2">
-            <a:schemeClr val="accent1"/>
-          </a:effectRef>
-          <a:fontRef idx="minor">
-            <a:schemeClr val="lt1"/>
-          </a:fontRef>
-        </p:style>
-        <p:txBody>
-          <a:bodyPr rtlCol="0" anchor="ctr"/>
-          <a:lstStyle/>
-          <a:p>
-            <a:pPr algn="ctr"/>
-          </a:p>
-        </p:txBody>
-      </p:sp>
-      <p:sp>
-        <p:nvSpPr>
-          <p:cNvPr id="14" name="TextBox 13"/>
-          <p:cNvSpPr txBox="1"/>
-          <p:nvPr/>
-        </p:nvSpPr>
-        <p:spPr>
-          <a:xfrm>
-            <a:off x="594360" y="4892040"/>
-            <a:ext cx="5029200" cy="411480"/>
-          </a:xfrm>
-          <a:prstGeom prst="rect">
-            <a:avLst/>
-          </a:prstGeom>
-          <a:noFill/>
-        </p:spPr>
-        <p:txBody>
-          <a:bodyPr wrap="none">
-            <a:spAutoFit/>
-          </a:bodyPr>
-          <a:lstStyle/>
-          <a:p>
-            <a:r>
-              <a:rPr sz="1500" b="1">
-                <a:solidFill>
-                  <a:srgbClr val="DC6400"/>
-                </a:solidFill>
-              </a:rPr>
-              <a:t>❹  MetaHuman pipeline</a:t>
-            </a:r>
-          </a:p>
-        </p:txBody>
-      </p:sp>
-      <p:sp>
-        <p:nvSpPr>
-          <p:cNvPr id="15" name="TextBox 14"/>
-          <p:cNvSpPr txBox="1"/>
-          <p:nvPr/>
-        </p:nvSpPr>
-        <p:spPr>
-          <a:xfrm>
-            <a:off x="594360" y="5303520"/>
-            <a:ext cx="10908792" cy="685800"/>
-          </a:xfrm>
-          <a:prstGeom prst="rect">
-            <a:avLst/>
-          </a:prstGeom>
-          <a:noFill/>
-        </p:spPr>
-        <p:txBody>
-          <a:bodyPr wrap="square">
-            <a:spAutoFit/>
-          </a:bodyPr>
-          <a:lstStyle/>
-          <a:p>
-            <a:r>
-              <a:rPr sz="1200">
-                <a:solidFill>
-                  <a:srgbClr val="BED2EB"/>
-                </a:solidFill>
-              </a:rPr>
-              <a:t>LiDAR scanning + C3D data → patient-specific MetaHuman avatars. Future roadmap: clinical digital twins for pre-surgical planning.</a:t>
             </a:r>
           </a:p>
         </p:txBody>

</xml_diff>